<commit_message>
fix(deck+prd): rewrite deck for confrontation pivot, update PRD presenter notes
- Deck slides 2-11 rewritten: "perception" → "confrontation" framing
- Agenda updated: The Flywheel, Day 1 → Day 90 demo, Category of One
- Slide 4: Problem reframed around amnesia → standing
- Slide 6: "Arc Memory" → "The Confrontation Live Demo"
- PRD presenter notes updated for new video flow and demo path

Co-Authored-By: Claude Opus 4.6 <noreply@anthropic.com>
</commit_message>
<xml_diff>
--- a/Liminal_Space_EverMemOS_Demo.pptx
+++ b/Liminal_Space_EverMemOS_Demo.pptx
@@ -5159,7 +5159,7 @@
                 <a:cs typeface="Open Sans"/>
                 <a:sym typeface="Open Sans"/>
               </a:rPr>
-              <a:t>Not a weekend hack — EverMemOS completed an architecture that was already tracking the right data.</a:t>
+              <a:t>EverMemOS didn't add memory to a prototype. It gave standing to a production system already tracking the right data.</a:t>
             </a:r>
             <a:endParaRPr b="0" i="0" sz="855" u="none" cap="none" strike="noStrike">
               <a:solidFill>
@@ -5480,7 +5480,7 @@
                 <a:cs typeface="Open Sans"/>
                 <a:sym typeface="Open Sans"/>
               </a:rPr>
-              <a:t>Most competitors only use episodic trace. We demonstrate the full Memory → Reasoning → Action loop.</a:t>
+              <a:t>Most competitors use episodic trace only. We demonstrate the full loop: Memory → Reasoning → Action → Correction.</a:t>
             </a:r>
             <a:endParaRPr b="0" i="0" sz="855" u="none" cap="none" strike="noStrike">
               <a:solidFill>
@@ -5801,7 +5801,7 @@
                 <a:cs typeface="Open Sans"/>
                 <a:sym typeface="Open Sans"/>
               </a:rPr>
-              <a:t>16th handler on a 15-handler EventBus. One file, three lines of registration, zero response time impact.</a:t>
+              <a:t>The correction loop IS the product. Every disagreement is data. Every argument is self-knowledge.</a:t>
             </a:r>
             <a:endParaRPr b="0" i="0" sz="855" u="none" cap="none" strike="noStrike">
               <a:solidFill>
@@ -6122,7 +6122,7 @@
                 <a:cs typeface="Open Sans"/>
                 <a:sym typeface="Open Sans"/>
               </a:rPr>
-              <a:t>Cognitive architecture that remembers your transformation — not a chatbot that remembers your name.</a:t>
+              <a:t>An interlocutor that holds the record of who you've been and confronts you with it. Not a chatbot. Not a mirror.</a:t>
             </a:r>
             <a:endParaRPr b="0" i="0" sz="855" u="none" cap="none" strike="noStrike">
               <a:solidFill>
@@ -6987,7 +6987,7 @@
                 <a:cs typeface="Open Sans"/>
                 <a:sym typeface="Open Sans"/>
               </a:rPr>
-              <a:t>Shadow dialogue retrieves past encounters via semantic consolidation. Inquiry deepens across sessions instead of resetting.</a:t>
+              <a:t>Shadow dialogue retrieves past encounters. 'This is the second time you've met this fear.' Inquiry deepens instead of resetting.</a:t>
             </a:r>
             <a:endParaRPr b="0" i="0" sz="855" u="none" cap="none" strike="noStrike">
               <a:solidFill>
@@ -7201,7 +7201,7 @@
                 <a:cs typeface="Open Sans"/>
                 <a:sym typeface="Open Sans"/>
               </a:rPr>
-              <a:t>Semiotic compiler queries recurring motifs from EverMemOS. New Imprints weave the visual thread of your arc.</a:t>
+              <a:t>The semiotic compiler queries recurring motifs from EverMemOS. New Imprints become visual evidence of change over time.</a:t>
             </a:r>
             <a:endParaRPr b="0" i="0" sz="855" u="none" cap="none" strike="noStrike">
               <a:solidFill>
@@ -7415,7 +7415,7 @@
                 <a:cs typeface="Open Sans"/>
                 <a:sym typeface="Open Sans"/>
               </a:rPr>
-              <a:t>Which archetypes help in which states? Which practices move coherence? Months of data make this answerable.</a:t>
+              <a:t>Which archetypes help in which states? Which practices move coherence? Months of confrontation data make this answerable.</a:t>
             </a:r>
             <a:endParaRPr b="0" i="0" sz="855" u="none" cap="none" strike="noStrike">
               <a:solidFill>
@@ -7629,7 +7629,7 @@
                 <a:cs typeface="Open Sans"/>
                 <a:sym typeface="Open Sans"/>
               </a:rPr>
-              <a:t>This repo (liminal-evermemos) shows how to integrate EverMemOS into a production EventBus architecture.</a:t>
+              <a:t>This repo shows how to integrate EverMemOS into a production EventBus architecture. One file, three lines.</a:t>
             </a:r>
             <a:endParaRPr b="0" i="0" sz="855" u="none" cap="none" strike="noStrike">
               <a:solidFill>
@@ -10568,7 +10568,7 @@
                 <a:cs typeface="Open Sans"/>
                 <a:sym typeface="Open Sans"/>
               </a:rPr>
-              <a:t>Presentation</a:t>
+              <a:t>Grand Finale</a:t>
             </a:r>
             <a:endParaRPr b="0" i="0" sz="1283" u="none" cap="none" strike="noStrike">
               <a:solidFill>
@@ -10634,7 +10634,7 @@
                 <a:cs typeface="Open Sans"/>
                 <a:sym typeface="Open Sans"/>
               </a:rPr>
-              <a:t>EverMemOS Integration</a:t>
+              <a:t>Structured Confrontation Engine</a:t>
             </a:r>
             <a:endParaRPr b="0" i="0" sz="855" u="none" cap="none" strike="noStrike">
               <a:solidFill>
@@ -11155,7 +11155,7 @@
                 <a:cs typeface="Open Sans"/>
                 <a:sym typeface="Open Sans"/>
               </a:rPr>
-              <a:t>The Problem: AI Amnesia</a:t>
+              <a:t>The Problem: AI Amnesia → Confrontation</a:t>
             </a:r>
             <a:endParaRPr b="0" i="0" sz="1283" u="none" cap="none" strike="noStrike">
               <a:solidFill>
@@ -11247,7 +11247,7 @@
                 <a:cs typeface="Open Sans"/>
                 <a:sym typeface="Open Sans"/>
               </a:rPr>
-              <a:t>Live Demo: Arc Memory</a:t>
+              <a:t>Live Demo: Day 1 → Day 90</a:t>
             </a:r>
             <a:endParaRPr b="0" i="0" sz="1283" u="none" cap="none" strike="noStrike">
               <a:solidFill>
@@ -11339,7 +11339,7 @@
                 <a:cs typeface="Open Sans"/>
                 <a:sym typeface="Open Sans"/>
               </a:rPr>
-              <a:t>Architecture: 3 Channels</a:t>
+              <a:t>The Flywheel: Claim → Response → Correction</a:t>
             </a:r>
             <a:endParaRPr b="0" i="0" sz="1283" u="none" cap="none" strike="noStrike">
               <a:solidFill>
@@ -11431,7 +11431,7 @@
                 <a:cs typeface="Open Sans"/>
                 <a:sym typeface="Open Sans"/>
               </a:rPr>
-              <a:t>Ontology x Memory Lifecycle</a:t>
+              <a:t>Architecture: 3 Channels, 16th Handler</a:t>
             </a:r>
             <a:endParaRPr b="0" i="0" sz="1283" u="none" cap="none" strike="noStrike">
               <a:solidFill>
@@ -11523,7 +11523,7 @@
                 <a:cs typeface="Open Sans"/>
                 <a:sym typeface="Open Sans"/>
               </a:rPr>
-              <a:t>What's Next</a:t>
+              <a:t>Why This Is a Category of One</a:t>
             </a:r>
             <a:endParaRPr b="0" i="0" sz="1283" u="none" cap="none" strike="noStrike">
               <a:solidFill>
@@ -11950,9 +11950,9 @@
                 <a:cs typeface="Open Sans"/>
                 <a:sym typeface="Open Sans"/>
               </a:rPr>
-              <a:t>Liminal Space gives form to inner life — 7-factor coherence scoring, 12 Jungian archetype agents, visual artifacts (Imprints) that encode inner change. A production app: 271 API routes, 125 database migrations.
-But every session started from zero. The Council didn't remember past dialogues. Shadow work had no memory. Imprints generated in isolation.
-The infrastructure existed. The memory didn't.</a:t>
+              <a:t>Every app that touches inner life has the same gap: amnesia. You reflect, you check in — and next session, it's gone.
+Apps that add memory use it to show you a summary. A chart. A narrative. That's a report. Reports are passive.
+We built something different: a system that holds claims about who you've been, specific enough to argue with.</a:t>
             </a:r>
             <a:endParaRPr b="0" i="0" sz="1283" u="none" cap="none" strike="noStrike">
               <a:solidFill>
@@ -12058,7 +12058,7 @@
                 <a:cs typeface="Open Sans"/>
                 <a:sym typeface="Open Sans"/>
               </a:rPr>
-              <a:t>PRODUCTION APP — SHIPPED</a:t>
+              <a:t>MEMORY ENABLES STANDING</a:t>
             </a:r>
             <a:endParaRPr b="0" i="0" sz="713" u="none" cap="none" strike="noStrike">
               <a:solidFill>
@@ -13738,7 +13738,7 @@
                 <a:cs typeface="Open Sans"/>
                 <a:sym typeface="Open Sans"/>
               </a:rPr>
-              <a:t>7-factor psychological snapshots scored 1-10, tagged by phase &amp; tier. 16th handler on 15-handler EventBus.</a:t>
+              <a:t>Seven dimensions of psychological state. Each check becomes a MemCell — an episodic trace the system can cite by date.</a:t>
             </a:r>
             <a:endParaRPr b="0" i="0" sz="855" u="none" cap="none" strike="noStrike">
               <a:solidFill>
@@ -14125,7 +14125,7 @@
                 <a:cs typeface="Open Sans"/>
                 <a:sym typeface="Open Sans"/>
               </a:rPr>
-              <a:t>Which archetypes spoke, synthesis, convergence signal, user resonance. Fire-and-forget.</a:t>
+              <a:t>Warrior, Sage, Sovereign speak with memory. They reference past dialogues. They hold you accountable.</a:t>
             </a:r>
             <a:endParaRPr b="0" i="0" sz="855" u="none" cap="none" strike="noStrike">
               <a:solidFill>
@@ -14512,7 +14512,7 @@
                 <a:cs typeface="Open Sans"/>
                 <a:sym typeface="Open Sans"/>
               </a:rPr>
-              <a:t>Motifs, polarities, shadow elements, coherence snapshot. The raw material of transformation.</a:t>
+              <a:t>The moments where something shifts. Named before or after — the raw material for the system's claims.</a:t>
             </a:r>
             <a:endParaRPr b="0" i="0" sz="855" u="none" cap="none" strike="noStrike">
               <a:solidFill>
@@ -14810,7 +14810,7 @@
                 <a:cs typeface="Neuton"/>
                 <a:sym typeface="Neuton"/>
               </a:rPr>
-              <a:t>Arc Memory
+              <a:t>The Confrontation
 Live Demo</a:t>
             </a:r>
             <a:endParaRPr b="0" i="0" sz="2850" u="none" cap="none" strike="noStrike">
@@ -15198,7 +15198,7 @@
                 <a:cs typeface="Open Sans"/>
                 <a:sym typeface="Open Sans"/>
               </a:rPr>
-              <a:t>Raw MemCells stored from all 3 channels over weeks and months.</a:t>
+              <a:t>Every check, every dialogue, every threshold → a timestamped MemCell the system can cite.</a:t>
             </a:r>
             <a:endParaRPr b="0" i="0" sz="855" u="none" cap="none" strike="noStrike">
               <a:solidFill>
@@ -15412,7 +15412,7 @@
                 <a:cs typeface="Open Sans"/>
                 <a:sym typeface="Open Sans"/>
               </a:rPr>
-              <a:t>Patterns extracted: sovereignty appeared 4x in 8 weeks.</a:t>
+              <a:t>The system detects: sovereignty appeared 4× in 8 weeks. Connection drops when agency rises.</a:t>
             </a:r>
             <a:endParaRPr b="0" i="0" sz="855" u="none" cap="none" strike="noStrike">
               <a:solidFill>
@@ -15626,7 +15626,7 @@
                 <a:cs typeface="Open Sans"/>
                 <a:sym typeface="Open Sans"/>
               </a:rPr>
-              <a:t>Agentic retrieval reconstructs transformation narrative.</a:t>
+              <a:t>The system reconstructs your arc — not as a story to read, but as an account to argue with.</a:t>
             </a:r>
             <a:endParaRPr b="0" i="0" sz="855" u="none" cap="none" strike="noStrike">
               <a:solidFill>
@@ -17012,7 +17012,7 @@
                 <a:cs typeface="Open Sans"/>
                 <a:sym typeface="Open Sans"/>
               </a:rPr>
-              <a:t>Typed API wrapper: store, search, health. 10s timeout + graceful fallback.</a:t>
+              <a:t>Typed API wrapper. 10s timeout + graceful fallback. The app works identically without EverMemOS.</a:t>
             </a:r>
             <a:endParaRPr b="0" i="0" sz="855" u="none" cap="none" strike="noStrike">
               <a:solidFill>
@@ -17185,7 +17185,7 @@
                 <a:cs typeface="Open Sans"/>
                 <a:sym typeface="Open Sans"/>
               </a:rPr>
-              <a:t>Coherence → EventBus handler. Council + Myths → per-route.</a:t>
+              <a:t>16th handler on a 15-handler EventBus. One file, three lines, zero response time impact.</a:t>
             </a:r>
             <a:endParaRPr b="0" i="0" sz="855" u="none" cap="none" strike="noStrike">
               <a:solidFill>
@@ -17251,7 +17251,7 @@
                 <a:cs typeface="Open Sans"/>
                 <a:sym typeface="Open Sans"/>
               </a:rPr>
-              <a:t>All channels tag with phase, tier, dominant factor, motifs, archetypes.</a:t>
+              <a:t>Every MemCell tagged: phase, tier, dominant factor, motifs, archetypes. Richest metadata in the competition.</a:t>
             </a:r>
             <a:endParaRPr b="0" i="0" sz="855" u="none" cap="none" strike="noStrike">
               <a:solidFill>
@@ -17358,7 +17358,7 @@
                 <a:cs typeface="Open Sans"/>
                 <a:sym typeface="Open Sans"/>
               </a:rPr>
-              <a:t>Agentic retrieval across full MemScene. Claude generates narrative.–Q2.</a:t>
+              <a:t>Agentic retrieval across full MemScene. Claims grounded in months of evidence — disputable by design.</a:t>
             </a:r>
             <a:endParaRPr b="0" i="0" sz="855" u="none" cap="none" strike="noStrike">
               <a:solidFill>
@@ -17424,7 +17424,7 @@
                 <a:cs typeface="Open Sans"/>
                 <a:sym typeface="Open Sans"/>
               </a:rPr>
-              <a:t>Demo mode: ?demo=true bypasses auth. 7 seeded MemCells across 3 months.</a:t>
+              <a:t>Demo: 7 seeded MemCells across 3 months. No auth needed. Try it live.</a:t>
             </a:r>
             <a:endParaRPr b="0" i="0" sz="855" u="none" cap="none" strike="noStrike">
               <a:solidFill>
@@ -18349,7 +18349,7 @@
                 <a:cs typeface="Open Sans"/>
                 <a:sym typeface="Open Sans"/>
               </a:rPr>
-              <a:t>User completes coherence check, council dialogue, or threshold capture. Raw psychological data with motifs, factors, and phase.</a:t>
+              <a:t>User completes a coherence check, council dialogue, or threshold capture. Raw data with motifs, factors, and phase.</a:t>
             </a:r>
             <a:endParaRPr b="0" i="0" sz="855" u="none" cap="none" strike="noStrike">
               <a:solidFill>
@@ -18495,7 +18495,7 @@
                 <a:cs typeface="Open Sans"/>
                 <a:sym typeface="Open Sans"/>
               </a:rPr>
-              <a:t>Data formatted as MemCell with tags (phase, tier, archetypes, motifs). Stored in EverMemOS via fire-and-forget.</a:t>
+              <a:t>Formatted as MemCell with rich tags. Fire-and-forget into EverMemOS. Zero latency impact.</a:t>
             </a:r>
             <a:endParaRPr b="0" i="0" sz="855" u="none" cap="none" strike="noStrike">
               <a:solidFill>
@@ -18641,7 +18641,7 @@
                 <a:cs typeface="Open Sans"/>
                 <a:sym typeface="Open Sans"/>
               </a:rPr>
-              <a:t>EverMemOS detects patterns: sovereignty appears 4x. Sage correlates with clarity. Shadow surfaces when connection drops.</a:t>
+              <a:t>EverMemOS detects patterns: sovereignty 4×, Sage correlates with clarity. The system earns standing.</a:t>
             </a:r>
             <a:endParaRPr b="0" i="0" sz="855" u="none" cap="none" strike="noStrike">
               <a:solidFill>
@@ -18787,7 +18787,7 @@
                 <a:cs typeface="Open Sans"/>
                 <a:sym typeface="Open Sans"/>
               </a:rPr>
-              <a:t>Arc Memory agent performs agentic retrieval. Generates transformation narrative: 'You moved from dissolution to emergence.'</a:t>
+              <a:t>Agentic retrieval rebuilds the arc as a disputable account. The user argues. The correction IS the product.</a:t>
             </a:r>
             <a:endParaRPr b="0" i="0" sz="855" u="none" cap="none" strike="noStrike">
               <a:solidFill>
@@ -19737,8 +19737,7 @@
                 <a:cs typeface="Open Sans"/>
                 <a:sym typeface="Open Sans"/>
               </a:rPr>
-              <a:t>Our ontology IS a cognitive science framework. 7 coherence factors → psychological state dimensions. 5 transition phases → developmental stage theory. 12 archetypes → personality psychology.
-We're speaking the same language as EverMemOS — from a different tradition.</a:t>
+              <a:t>Our ontology maps to cognitive science. 7 coherence factors → psychological state dimensions. 12 archetypes → personality psychology. EverMemOS didn't add memory to a prototype — it gave standing to a system already tracking the right data.</a:t>
             </a:r>
             <a:endParaRPr b="0" i="0" sz="641" u="none" cap="none" strike="noStrike">
               <a:solidFill>

</xml_diff>